<commit_message>
docs: update README with React frontend quickstart, add ARCHITECTURE.md, evaluation plan, and preserve project docs
</commit_message>
<xml_diff>
--- a/docs/review2.pptx
+++ b/docs/review2.pptx
@@ -277,7 +277,7 @@
       </p15:sldGuideLst>
     </p:ext>
     <p:ext uri="GoogleSlidesCustomDataVersion2">
-      <go:slidesCustomData xmlns:go="http://customooxmlschemas.google.com/" xmlns:ahyp="http://schemas.microsoft.com/office/drawing/2018/hyperlinkcolor" xmlns:p15="http://schemas.microsoft.com/office/powerpoint/2012/main" xmlns:p14="http://schemas.microsoft.com/office/powerpoint/2010/main" xmlns:com="http://schemas.openxmlformats.org/drawingml/2006/compatibility" xmlns:pvml="urn:schemas-microsoft-com:office:powerpoint" xmlns:v="urn:schemas-microsoft-com:vml" xmlns:o="urn:schemas-microsoft-com:office:office" xmlns:dgm="http://schemas.openxmlformats.org/drawingml/2006/diagram" xmlns:c="http://schemas.openxmlformats.org/drawingml/2006/chart" xmlns:mv="urn:schemas-microsoft-com:mac:vml" xmlns:mc="http://schemas.openxmlformats.org/markup-compatibility/2006" xmlns="" r:id="rId25" roundtripDataSignature="AMtx7mibiUFiU9NruQE/u+j9j+AbzG2rLw=="/>
+      <go:slidesCustomData xmlns="" xmlns:mc="http://schemas.openxmlformats.org/markup-compatibility/2006" xmlns:mv="urn:schemas-microsoft-com:mac:vml" xmlns:c="http://schemas.openxmlformats.org/drawingml/2006/chart" xmlns:dgm="http://schemas.openxmlformats.org/drawingml/2006/diagram" xmlns:o="urn:schemas-microsoft-com:office:office" xmlns:v="urn:schemas-microsoft-com:vml" xmlns:pvml="urn:schemas-microsoft-com:office:powerpoint" xmlns:com="http://schemas.openxmlformats.org/drawingml/2006/compatibility" xmlns:p14="http://schemas.microsoft.com/office/powerpoint/2010/main" xmlns:p15="http://schemas.microsoft.com/office/powerpoint/2012/main" xmlns:ahyp="http://schemas.microsoft.com/office/drawing/2018/hyperlinkcolor" xmlns:go="http://customooxmlschemas.google.com/" r:id="rId25" roundtripDataSignature="AMtx7mibiUFiU9NruQE/u+j9j+AbzG2rLw=="/>
     </p:ext>
   </p:extLst>
 </p:presentation>
@@ -15429,7 +15429,7 @@
         <p:spPr>
           <a:xfrm>
             <a:off x="5867400" y="4086635"/>
-            <a:ext cx="12039600" cy="617700"/>
+            <a:ext cx="12039600" cy="863313"/>
           </a:xfrm>
           <a:prstGeom prst="rect">
             <a:avLst/>
@@ -15463,7 +15463,7 @@
               <a:buNone/>
             </a:pPr>
             <a:r>
-              <a:rPr lang="en-US" sz="2200" b="1" i="0" u="none" strike="noStrike" cap="none">
+              <a:rPr lang="en-US" sz="2200" b="1" i="0" u="none" strike="noStrike" cap="none" dirty="0">
                 <a:solidFill>
                   <a:srgbClr val="173764"/>
                 </a:solidFill>
@@ -15475,7 +15475,7 @@
               <a:t>Name of the Guide: </a:t>
             </a:r>
             <a:r>
-              <a:rPr lang="en-US" sz="2200" b="0" i="0" u="none" strike="noStrike" cap="none">
+              <a:rPr lang="en-US" sz="2200" b="0" i="0" u="none" strike="noStrike" cap="none" dirty="0">
                 <a:solidFill>
                   <a:srgbClr val="173764"/>
                 </a:solidFill>
@@ -15484,7 +15484,19 @@
                 <a:cs typeface="Poppins"/>
                 <a:sym typeface="Poppins"/>
               </a:rPr>
-              <a:t>Prof Shital Gujar</a:t>
+              <a:t>Prof </a:t>
+            </a:r>
+            <a:r>
+              <a:rPr lang="en-US" sz="2200" b="0" i="0" u="none" strike="noStrike" cap="none">
+                <a:solidFill>
+                  <a:srgbClr val="173764"/>
+                </a:solidFill>
+                <a:latin typeface="Poppins"/>
+                <a:ea typeface="Poppins"/>
+                <a:cs typeface="Poppins"/>
+                <a:sym typeface="Poppins"/>
+              </a:rPr>
+              <a:t>Swati Gaikwad</a:t>
             </a:r>
             <a:endParaRPr sz="1400" b="0" i="0" u="none" strike="noStrike" cap="none">
               <a:solidFill>

</xml_diff>